<commit_message>
Sesión 5: adjuntar no es RAG, y el bibliotecario eres tú
El Instituto tiene Copilot Chat sin la licencia de paga Microsoft 365
Copilot, así que no hay índice semántico sobre OneDrive: adjuntar un
archivo equivale a subirlo a la conversación. El bloque de RAG se ajustó
a esa realidad.

- Lámina nueva que distingue la ventana de contexto (el escritorio) del
  RAG (la biblioteca con bibliotecario), con sus fuentes.
- El Tu turno y la lámina de búsqueda por cercanía se reescribieron, con
  notas de ponente; el bloque empieza a las 11:07.
- Anexo visual de nueve láminas para la charla opcional del receso:
  piezas, costos, cómo falla cada camino y fuentes verificadas.
- NotebookLM hoy se llama Gemini Notebook; la cuenta gratuita de You.com
  es una prueba de 25 consultas (aviso al equipo 4).
- Handout y temario alineados, con nota fechada del ajuste.

Co-Authored-By: Claude Fable 5.1 <noreply@anthropic.com>
</commit_message>
<xml_diff>
--- a/sesion-05/Sesion_05_Ecosistema_Herramientas.pptx
+++ b/sesion-05/Sesion_05_Ecosistema_Herramientas.pptx
@@ -20,6 +20,7 @@
     <p:sldId id="268" r:id="rId14"/>
     <p:sldId id="269" r:id="rId15"/>
     <p:sldId id="270" r:id="rId16"/>
+    <p:sldId id="274" r:id="rId25"/>
     <p:sldId id="273" r:id="rId24"/>
     <p:sldId id="271" r:id="rId17"/>
     <p:sldId id="272" r:id="rId18"/>
@@ -1135,9 +1136,44 @@
           <a:p>
             <a:r>
               <a:rPr lang="en-US" dirty="0"/>
-              <a:t/>
-            </a:r>
-            <a:endParaRPr lang="en-US" dirty="0"/>
+              <a:t>Diez minutos de reloj. Mecánica: cada quien trabaja en su OneDrive institucional, con documentos de nivel verde o amarillo de su tema.</a:t>
+            </a:r>
+          </a:p>
+          <a:p>
+            <a:r>
+              <a:rPr lang="en-US" dirty="0"/>
+              <a:t>Minutos 0 a 3: crear o elegir una carpeta por asunto y renombrar tres o cuatro archivos para que el nombre diga qué contienen.</a:t>
+            </a:r>
+          </a:p>
+          <a:p>
+            <a:r>
+              <a:rPr lang="en-US" dirty="0"/>
+              <a:t>Minutos 3 a 8: en Copilot Chat, adjuntar desde OneDrive los archivos que responden una pregunta real de su trabajo, preguntar y pedir la cita del párrafo. Luego repetir la misma pregunta en un chat nuevo sin adjuntar nada.</a:t>
+            </a:r>
+          </a:p>
+          <a:p>
+            <a:r>
+              <a:rPr lang="en-US" dirty="0"/>
+              <a:t>Minutos 8 a 10: dos o tres personas cuentan la diferencia. Lo que debe salir: sin adjuntos responde de memoria y de la web; con adjuntos responde con tus documentos, pero solo con los que tú elegiste.</a:t>
+            </a:r>
+          </a:p>
+          <a:p>
+            <a:r>
+              <a:rPr lang="en-US" dirty="0"/>
+              <a:t>Por qué cambió esta práctica: el Instituto tiene Copilot Chat (Basic). Sin la licencia de paga no hay índice semántico ni búsqueda sobre todo OneDrive; el menú de archivos busca por nombre y actividad reciente solo para que tú elijas. Por eso los nombres descriptivos siguen importando.</a:t>
+            </a:r>
+          </a:p>
+          <a:p>
+            <a:r>
+              <a:rPr lang="en-US" dirty="0"/>
+              <a:t>Cada quien puede confirmar su etiqueta en m365.cloud.microsoft, al pie de la página de inicio, bajo su nombre.</a:t>
+            </a:r>
+          </a:p>
+          <a:p>
+            <a:r>
+              <a:rPr lang="en-US" dirty="0"/>
+              <a:t>Advertencia útil: con un documento muy largo no des por hecho que lo leyó completo. Pregunta por una sección intermedia o pártelo. Microsoft no publica un límite de archivos por conversación para Copilot Chat de trabajo; no cites cifras.</a:t>
+            </a:r>
           </a:p>
         </p:txBody>
       </p:sp>
@@ -1156,7 +1192,7 @@
           <a:bodyPr/>
           <a:lstStyle/>
           <a:p>
-            <a:fld id="{F7021451-1387-4CA6-816F-3879F97B5CBC}" type="slidenum">
+            <a:fld id="{B3C21451-1387-4CA6-816F-3879F97B5CB9}" type="slidenum">
               <a:rPr lang="en-US"/>
               <a:t>16</a:t>
             </a:fld>
@@ -1165,11 +1201,6 @@
         </p:txBody>
       </p:sp>
     </p:spTree>
-    <p:extLst>
-      <p:ext uri="{BB962C8B-B14F-4D97-AF65-F5344CB8AC3E}">
-        <p14:creationId xmlns:p14="http://schemas.microsoft.com/office/powerpoint/2010/main" val="1024086991"/>
-      </p:ext>
-    </p:extLst>
   </p:cSld>
   <p:clrMapOvr>
     <a:masterClrMapping/>
@@ -1258,6 +1289,218 @@
         <p14:creationId xmlns:p14="http://schemas.microsoft.com/office/powerpoint/2010/main" val="1024086991"/>
       </p:ext>
     </p:extLst>
+  </p:cSld>
+  <p:clrMapOvr>
+    <a:masterClrMapping/>
+  </p:clrMapOvr>
+</p:notes>
+</file>
+
+<file path=ppt/notesSlides/notesSlide18.xml><?xml version="1.0" encoding="utf-8"?>
+<p:notes xmlns:a="http://schemas.openxmlformats.org/drawingml/2006/main" xmlns:r="http://schemas.openxmlformats.org/officeDocument/2006/relationships" xmlns:p="http://schemas.openxmlformats.org/presentationml/2006/main">
+  <p:cSld>
+    <p:spTree>
+      <p:nvGrpSpPr>
+        <p:cNvPr id="1" name=""/>
+        <p:cNvGrpSpPr/>
+        <p:nvPr/>
+      </p:nvGrpSpPr>
+      <p:grpSpPr>
+        <a:xfrm>
+          <a:off x="0" y="0"/>
+          <a:ext cx="0" cy="0"/>
+          <a:chOff x="0" y="0"/>
+          <a:chExt cx="0" cy="0"/>
+        </a:xfrm>
+      </p:grpSpPr>
+      <p:sp>
+        <p:nvSpPr>
+          <p:cNvPr id="2" name="Slide Image Placeholder 1"/>
+          <p:cNvSpPr>
+            <a:spLocks noGrp="1" noRot="1" noChangeAspect="1"/>
+          </p:cNvSpPr>
+          <p:nvPr>
+            <p:ph type="sldImg"/>
+          </p:nvPr>
+        </p:nvSpPr>
+        <p:spPr/>
+      </p:sp>
+      <p:sp>
+        <p:nvSpPr>
+          <p:cNvPr id="3" name="Notes Placeholder 2"/>
+          <p:cNvSpPr>
+            <a:spLocks noGrp="1"/>
+          </p:cNvSpPr>
+          <p:nvPr>
+            <p:ph type="body" idx="1"/>
+          </p:nvPr>
+        </p:nvSpPr>
+        <p:spPr/>
+        <p:txBody>
+          <a:bodyPr/>
+          <a:lstStyle/>
+          <a:p>
+            <a:r>
+              <a:rPr lang="en-US" dirty="0"/>
+              <a:t>Dos minutos. Es la lámina del viernes aplicada a documentos: partir, convertir en coordenadas, recuperar lo más cercano.</a:t>
+            </a:r>
+          </a:p>
+          <a:p>
+            <a:r>
+              <a:rPr lang="en-US" dirty="0"/>
+              <a:t>Cierra con el dato del banner: los equipos 4, 5 y 6 ya usaron RAG esta mañana sin llamarlo así. Perplexity, Elicit y Consensus buscan antes de escribir; por eso traen citas.</a:t>
+            </a:r>
+          </a:p>
+          <a:p>
+            <a:r>
+              <a:rPr lang="en-US" dirty="0"/>
+              <a:t>Precisión para el grupo técnico: los sistemas reales casi nunca buscan solo por cercanía de significado. Combinan cercanía con coincidencia de palabras (búsqueda híbrida) y reordenan los resultados antes de entregarlos al modelo.</a:t>
+            </a:r>
+          </a:p>
+          <a:p>
+            <a:r>
+              <a:rPr lang="en-US" dirty="0"/>
+              <a:t>El puente a la práctica: en el Copilot Chat del Instituto no hay buscador sobre tu OneDrive. Microsoft reserva el índice semántico a la licencia de paga Microsoft 365 Copilot. Adjuntar o referenciar un archivo equivale a subirlo a la conversación.</a:t>
+            </a:r>
+          </a:p>
+        </p:txBody>
+      </p:sp>
+      <p:sp>
+        <p:nvSpPr>
+          <p:cNvPr id="4" name="Slide Number Placeholder 3"/>
+          <p:cNvSpPr>
+            <a:spLocks noGrp="1"/>
+          </p:cNvSpPr>
+          <p:nvPr>
+            <p:ph type="sldNum" sz="quarter" idx="10"/>
+          </p:nvPr>
+        </p:nvSpPr>
+        <p:spPr/>
+        <p:txBody>
+          <a:bodyPr/>
+          <a:lstStyle/>
+          <a:p>
+            <a:fld id="{B3C21451-1387-4CA6-816F-3879F97B5CB9}" type="slidenum">
+              <a:rPr lang="en-US"/>
+              <a:t>18</a:t>
+            </a:fld>
+            <a:endParaRPr lang="en-US"/>
+          </a:p>
+        </p:txBody>
+      </p:sp>
+    </p:spTree>
+  </p:cSld>
+  <p:clrMapOvr>
+    <a:masterClrMapping/>
+  </p:clrMapOvr>
+</p:notes>
+</file>
+
+<file path=ppt/notesSlides/notesSlide19.xml><?xml version="1.0" encoding="utf-8"?>
+<p:notes xmlns:a="http://schemas.openxmlformats.org/drawingml/2006/main" xmlns:r="http://schemas.openxmlformats.org/officeDocument/2006/relationships" xmlns:p="http://schemas.openxmlformats.org/presentationml/2006/main">
+  <p:cSld>
+    <p:spTree>
+      <p:nvGrpSpPr>
+        <p:cNvPr id="1" name=""/>
+        <p:cNvGrpSpPr/>
+        <p:nvPr/>
+      </p:nvGrpSpPr>
+      <p:grpSpPr>
+        <a:xfrm>
+          <a:off x="0" y="0"/>
+          <a:ext cx="0" cy="0"/>
+          <a:chOff x="0" y="0"/>
+          <a:chExt cx="0" cy="0"/>
+        </a:xfrm>
+      </p:grpSpPr>
+      <p:sp>
+        <p:nvSpPr>
+          <p:cNvPr id="2" name="Slide Image Placeholder 1"/>
+          <p:cNvSpPr>
+            <a:spLocks noGrp="1" noRot="1" noChangeAspect="1"/>
+          </p:cNvSpPr>
+          <p:nvPr>
+            <p:ph type="sldImg"/>
+          </p:nvPr>
+        </p:nvSpPr>
+        <p:spPr/>
+      </p:sp>
+      <p:sp>
+        <p:nvSpPr>
+          <p:cNvPr id="3" name="Notes Placeholder 2"/>
+          <p:cNvSpPr>
+            <a:spLocks noGrp="1"/>
+          </p:cNvSpPr>
+          <p:nvPr>
+            <p:ph type="body" idx="1"/>
+          </p:nvPr>
+        </p:nvSpPr>
+        <p:spPr/>
+        <p:txBody>
+          <a:bodyPr/>
+          <a:lstStyle/>
+          <a:p>
+            <a:r>
+              <a:rPr lang="en-US" dirty="0"/>
+              <a:t>Tres minutos. Es la única lámina de teoría del bloque; la profundidad va en el anexo y en la charla del receso.</a:t>
+            </a:r>
+          </a:p>
+          <a:p>
+            <a:r>
+              <a:rPr lang="en-US" dirty="0"/>
+              <a:t>Metáfora: adjuntar es poner los documentos sobre el escritorio; el modelo lee lo que tú pusiste. RAG es una biblioteca con bibliotecario: alguien indexó el acervo y un buscador trae los fragmentos que parecen pertinentes.</a:t>
+            </a:r>
+          </a:p>
+          <a:p>
+            <a:r>
+              <a:rPr lang="en-US" dirty="0"/>
+              <a:t>Para economistas: el escritorio no tiene costo fijo y su costo marginal crece con cada página que se procesa en cada pregunta. La biblioteca tiene costo fijo (armar y mantener el índice) y consultas baratas. Ninguna de las dos garantiza la respuesta.</a:t>
+            </a:r>
+          </a:p>
+          <a:p>
+            <a:r>
+              <a:rPr lang="en-US" dirty="0"/>
+              <a:t>Cómo falla cada una. Escritorio: Liu y otros («Lost in the Middle», TACL 2024) mostraron con modelos de 2023 que lo que queda en medio del contexto se aprovecha peor. Los modelos actuales lo mitigaron en búsquedas sencillas, pero su exactitud sigue bajando conforme crece el contexto (RULER, NoLiMa). Biblioteca: si el buscador no recupera el fragmento correcto, el modelo contesta sin él. Por eso es falso que el RAG «asegure» la respuesta exacta.</a:t>
+            </a:r>
+          </a:p>
+          <a:p>
+            <a:r>
+              <a:rPr lang="en-US" dirty="0"/>
+              <a:t>Dato para quien pregunte: ChatGPT no carga siempre el archivo completo. OpenAI documenta que en Enterprise pega en el contexto hasta cierto número de tokens y manda todo el texto a un índice privado del que recupera fragmentos. Es decir, hace RAG por dentro. No cites la cifra como fija: la página avisa que puede cambiar.</a:t>
+            </a:r>
+          </a:p>
+          <a:p>
+            <a:r>
+              <a:rPr lang="en-US" dirty="0"/>
+              <a:t>Si alguien técnico pide más (embeddings, búsqueda híbrida, reordenamiento, caché de prompts), remítelo al Anexo_Ventana_de_contexto_y_RAG.pptx. No abras ese frente aquí.</a:t>
+            </a:r>
+          </a:p>
+        </p:txBody>
+      </p:sp>
+      <p:sp>
+        <p:nvSpPr>
+          <p:cNvPr id="4" name="Slide Number Placeholder 3"/>
+          <p:cNvSpPr>
+            <a:spLocks noGrp="1"/>
+          </p:cNvSpPr>
+          <p:nvPr>
+            <p:ph type="sldNum" sz="quarter" idx="10"/>
+          </p:nvPr>
+        </p:nvSpPr>
+        <p:spPr/>
+        <p:txBody>
+          <a:bodyPr/>
+          <a:lstStyle/>
+          <a:p>
+            <a:fld id="{B3C21451-1387-4CA6-816F-3879F97B5CB9}" type="slidenum">
+              <a:rPr lang="en-US"/>
+              <a:t>19</a:t>
+            </a:fld>
+            <a:endParaRPr lang="en-US"/>
+          </a:p>
+        </p:txBody>
+      </p:sp>
+    </p:spTree>
   </p:cSld>
   <p:clrMapOvr>
     <a:masterClrMapping/>
@@ -4677,7 +4920,7 @@
                 <a:ea typeface="Calibri" pitchFamily="34" charset="-122"/>
                 <a:cs typeface="Calibri" pitchFamily="34" charset="-120"/>
               </a:rPr>
-              <a:t>10:50 a 11:10</a:t>
+              <a:t>10:50 a 11:07</a:t>
             </a:r>
             <a:endParaRPr lang="en-US" sz="1200" dirty="0"/>
           </a:p>
@@ -5054,7 +5297,7 @@
                 <a:ea typeface="Calibri" pitchFamily="34" charset="-122"/>
                 <a:cs typeface="Calibri" pitchFamily="34" charset="-120"/>
               </a:rPr>
-              <a:t>Responde citando el párrafo exacto de cada documento fuente.</a:t>
+              <a:t>Desde julio se llama Gemini Notebook. Responde citando el párrafo exacto de cada documento fuente.</a:t>
             </a:r>
             <a:endParaRPr lang="en-US" sz="1300" dirty="0"/>
           </a:p>
@@ -5489,7 +5732,7 @@
                 <a:ea typeface="Calibri" pitchFamily="34" charset="-122"/>
                 <a:cs typeface="Calibri" pitchFamily="34" charset="-120"/>
               </a:rPr>
-              <a:t>11:10 a 11:25</a:t>
+              <a:t>11:07 a 11:25</a:t>
             </a:r>
             <a:endParaRPr lang="en-US" sz="1200" dirty="0"/>
           </a:p>
@@ -5692,7 +5935,7 @@
                 <a:ea typeface="Arial" pitchFamily="34" charset="-122"/>
                 <a:cs typeface="Arial" pitchFamily="34" charset="-120"/>
               </a:rPr>
-              <a:t>OneDrive más Copilot Chat, anclados a una carpeta</a:t>
+              <a:t>Copilot Chat y OneDrive: el bibliotecario eres tú</a:t>
             </a:r>
             <a:endParaRPr lang="en-US" sz="2900" dirty="0"/>
           </a:p>
@@ -5825,7 +6068,7 @@
                 <a:ea typeface="Calibri" pitchFamily="34" charset="-122"/>
                 <a:cs typeface="Calibri" pitchFamily="34" charset="-120"/>
               </a:rPr>
-              <a:t>RAG quiere decir que la herramienta busca en tus documentos antes de responder, en lugar de contestar de memoria. Eso es lo que hace NotebookLM, y es lo que puedes armar con lo que ya tienes.</a:t>
+              <a:t>En un RAG, un buscador elige qué fragmentos lee el modelo. El Copilot Chat del Instituto no trae ese buscador: lee solo lo que tú le adjuntas. Hoy el paso de buscar lo haces tú.</a:t>
             </a:r>
             <a:endParaRPr lang="en-US" sz="1450" dirty="0"/>
           </a:p>
@@ -6091,7 +6334,7 @@
                 <a:ea typeface="Calibri" pitchFamily="34" charset="-122"/>
                 <a:cs typeface="Calibri" pitchFamily="34" charset="-120"/>
               </a:rPr>
-              <a:t>Nombra los archivos de manera que el nombre diga qué contiene. Copilot busca por nombre antes que por contenido.</a:t>
+              <a:t>Nombra los archivos de manera que el nombre diga qué contiene. Ese nombre es tu índice: con él decides qué adjuntar.</a:t>
             </a:r>
             <a:endParaRPr lang="en-US" sz="1450" dirty="0"/>
           </a:p>
@@ -6224,7 +6467,7 @@
                 <a:ea typeface="Calibri" pitchFamily="34" charset="-122"/>
                 <a:cs typeface="Calibri" pitchFamily="34" charset="-120"/>
               </a:rPr>
-              <a:t>Pregunta en Copilot Chat referenciando la carpeta o sus archivos, y compara contra la misma pregunta sin anclar. La diferencia suele ser grande.</a:t>
+              <a:t>Adjunta en Copilot Chat los archivos que responden tu pregunta y pide la cita del párrafo. Después haz la misma pregunta sin adjuntar nada y compara.</a:t>
             </a:r>
             <a:endParaRPr lang="en-US" sz="1450" dirty="0"/>
           </a:p>
@@ -6290,7 +6533,7 @@
                 <a:ea typeface="Calibri" pitchFamily="34" charset="-122"/>
                 <a:cs typeface="Calibri" pitchFamily="34" charset="-120"/>
               </a:rPr>
-              <a:t>Es lo único de hoy que funciona con información amarilla; lo demás que probaste es solo para información pública. Si tu área vive en SharePoint, el mismo método aplica: verifica primero que tu Copilot Chat alcance esa carpeta.</a:t>
+              <a:t>Es lo único de hoy que funciona con información amarilla; lo demás es solo para información pública. Con la licencia de paga Microsoft 365 Copilot, un índice buscaría por ti: es la que pone a Copilot dentro de Word y Excel, donde ya vimos que no aparece.</a:t>
             </a:r>
             <a:endParaRPr lang="en-US" sz="1350" dirty="0"/>
           </a:p>
@@ -7016,7 +7259,7 @@
                 <a:ea typeface="Arial" pitchFamily="34" charset="-122"/>
                 <a:cs typeface="Arial" pitchFamily="34" charset="-120"/>
               </a:rPr>
-              <a:t>Cómo busca: por cercanía, no por coincidencia</a:t>
+              <a:t>Cómo busca el bibliotecario: por cercanía</a:t>
             </a:r>
             <a:endParaRPr lang="en-US" sz="3200" dirty="0"/>
           </a:p>
@@ -7055,7 +7298,7 @@
                 <a:ea typeface="Calibri" pitchFamily="34" charset="-122"/>
                 <a:cs typeface="Calibri" pitchFamily="34" charset="-120"/>
               </a:rPr>
-              <a:t>Es la idea del viernes aplicada a tus carpetas. Saber cómo busca explica exactamente qué te toca hacer a ti.</a:t>
+              <a:t>Es la idea del viernes aplicada a documentos completos. Así trabajan por dentro las herramientas que buscan antes de escribir.</a:t>
             </a:r>
             <a:endParaRPr lang="en-US" sz="1500" dirty="0"/>
           </a:p>
@@ -7187,7 +7430,7 @@
                 <a:ea typeface="Arial" pitchFamily="34" charset="-122"/>
                 <a:cs typeface="Arial" pitchFamily="34" charset="-120"/>
               </a:rPr>
-              <a:t>Parte tus documentos</a:t>
+              <a:t>Parte los documentos</a:t>
             </a:r>
             <a:endParaRPr lang="en-US" sz="1600" dirty="0"/>
           </a:p>
@@ -7646,7 +7889,7 @@
                 <a:ea typeface="Calibri" pitchFamily="34" charset="-122"/>
                 <a:cs typeface="Calibri" pitchFamily="34" charset="-120"/>
               </a:rPr>
-              <a:t>De ahí salen las dos reglas de la práctica: un nombre que describe el contenido y una carpeta por asunto le dan señal para acercarse a lo que necesitas. Un documento gigante y revuelto se lo pone difícil, porque los fragmentos quedan mezclados.</a:t>
+              <a:t>Los equipos 4, 5 y 6 usaron RAG esta mañana: Perplexity, Elicit y Consensus buscan antes de escribir. En el Copilot Chat del Instituto ese buscador no existe, así que en la práctica que sigue quien elige los documentos eres tú.</a:t>
             </a:r>
             <a:endParaRPr lang="en-US" sz="1300" dirty="0"/>
           </a:p>
@@ -7685,7 +7928,1427 @@
                 <a:ea typeface="Calibri" pitchFamily="34" charset="-122"/>
                 <a:cs typeface="Calibri" pitchFamily="34" charset="-120"/>
               </a:rPr>
-              <a:t>La idea es la misma del viernes, cuando agrupaste Registros_atencion_ciudadana_PARTICIPANTE.xlsx; hoy se aplica a tu carpeta de OneDrive.</a:t>
+              <a:t>La idea es la misma del viernes, cuando agrupaste Registros_atencion_ciudadana_PARTICIPANTE.xlsx. Fuente: Lewis y otros (2020), arXiv:2005.11401.</a:t>
+            </a:r>
+            <a:endParaRPr lang="en-US" sz="1000" dirty="0"/>
+          </a:p>
+        </p:txBody>
+      </p:sp>
+    </p:spTree>
+  </p:cSld>
+  <p:clrMapOvr>
+    <a:masterClrMapping/>
+  </p:clrMapOvr>
+</p:sld>
+</file>
+
+<file path=ppt/slides/slide19.xml><?xml version="1.0" encoding="utf-8"?>
+<p:sld xmlns:a="http://schemas.openxmlformats.org/drawingml/2006/main" xmlns:r="http://schemas.openxmlformats.org/officeDocument/2006/relationships" xmlns:p="http://schemas.openxmlformats.org/presentationml/2006/main">
+  <p:cSld name="Adjuntar no es RAG">
+    <p:spTree>
+      <p:nvGrpSpPr>
+        <p:cNvPr id="1" name=""/>
+        <p:cNvGrpSpPr/>
+        <p:nvPr/>
+      </p:nvGrpSpPr>
+      <p:grpSpPr>
+        <a:xfrm>
+          <a:off x="0" y="0"/>
+          <a:ext cx="0" cy="0"/>
+          <a:chOff x="0" y="0"/>
+          <a:chExt cx="0" cy="0"/>
+        </a:xfrm>
+      </p:grpSpPr>
+      <p:sp>
+        <p:nvSpPr>
+          <p:cNvPr id="2" name="Text"/>
+          <p:cNvSpPr txBox="1"/>
+          <p:nvPr/>
+        </p:nvSpPr>
+        <p:spPr>
+          <a:xfrm>
+            <a:off x="566928" y="402336"/>
+            <a:ext cx="11057839" cy="749808"/>
+          </a:xfrm>
+          <a:prstGeom prst="rect">
+            <a:avLst/>
+          </a:prstGeom>
+          <a:noFill/>
+          <a:ln/>
+        </p:spPr>
+        <p:txBody>
+          <a:bodyPr wrap="square" lIns="0" tIns="0" rIns="0" bIns="0" rtlCol="0" anchor="t"/>
+          <a:lstStyle/>
+          <a:p>
+            <a:pPr algn="l" indent="0" marL="0">
+              <a:buNone/>
+            </a:pPr>
+            <a:r>
+              <a:rPr lang="en-US" sz="3200" b="1" dirty="0">
+                <a:solidFill>
+                  <a:srgbClr val="16262E"/>
+                </a:solidFill>
+                <a:latin typeface="Arial" pitchFamily="34" charset="0"/>
+                <a:ea typeface="Arial" pitchFamily="34" charset="-122"/>
+                <a:cs typeface="Arial" pitchFamily="34" charset="-120"/>
+              </a:rPr>
+              <a:t>Adjuntar no es lo mismo que RAG</a:t>
+            </a:r>
+            <a:endParaRPr lang="en-US" sz="3200" dirty="0"/>
+          </a:p>
+        </p:txBody>
+      </p:sp>
+      <p:sp>
+        <p:nvSpPr>
+          <p:cNvPr id="3" name="Text"/>
+          <p:cNvSpPr txBox="1"/>
+          <p:nvPr/>
+        </p:nvSpPr>
+        <p:spPr>
+          <a:xfrm>
+            <a:off x="566928" y="1230000"/>
+            <a:ext cx="11057839" cy="420000"/>
+          </a:xfrm>
+          <a:prstGeom prst="rect">
+            <a:avLst/>
+          </a:prstGeom>
+          <a:noFill/>
+          <a:ln/>
+        </p:spPr>
+        <p:txBody>
+          <a:bodyPr wrap="square" lIns="0" tIns="0" rIns="0" bIns="0" rtlCol="0" anchor="t"/>
+          <a:lstStyle/>
+          <a:p>
+            <a:pPr indent="0" marL="0">
+              <a:lnSpc>
+                <a:spcPct val="108000"/>
+              </a:lnSpc>
+              <a:buNone/>
+            </a:pPr>
+            <a:r>
+              <a:rPr lang="en-US" sz="1500" dirty="0">
+                <a:solidFill>
+                  <a:srgbClr val="5A6B73"/>
+                </a:solidFill>
+                <a:latin typeface="Calibri" pitchFamily="34" charset="0"/>
+                <a:ea typeface="Calibri" pitchFamily="34" charset="-122"/>
+                <a:cs typeface="Calibri" pitchFamily="34" charset="-120"/>
+              </a:rPr>
+              <a:t>Hay dos maneras de que un modelo trabaje con tus documentos. Desde fuera se parecen, y fallan de forma distinta.</a:t>
+            </a:r>
+            <a:endParaRPr lang="en-US" sz="1500" dirty="0"/>
+          </a:p>
+        </p:txBody>
+      </p:sp>
+      <p:sp>
+        <p:nvSpPr>
+          <p:cNvPr id="4" name="Shape"/>
+          <p:cNvSpPr/>
+          <p:nvPr/>
+        </p:nvSpPr>
+        <p:spPr>
+          <a:xfrm>
+            <a:off x="566928" y="1850000"/>
+            <a:ext cx="5378919" cy="3700000"/>
+          </a:xfrm>
+          <a:prstGeom prst="roundRect">
+            <a:avLst>
+              <a:gd name="adj" fmla="val 2933"/>
+            </a:avLst>
+          </a:prstGeom>
+          <a:solidFill>
+            <a:srgbClr val="F2F5F6"/>
+          </a:solidFill>
+          <a:ln w="12700">
+            <a:solidFill>
+              <a:srgbClr val="F2F5F6"/>
+            </a:solidFill>
+            <a:prstDash val="solid"/>
+          </a:ln>
+        </p:spPr>
+      </p:sp>
+      <p:sp>
+        <p:nvSpPr>
+          <p:cNvPr id="5" name="Text"/>
+          <p:cNvSpPr txBox="1"/>
+          <p:nvPr/>
+        </p:nvSpPr>
+        <p:spPr>
+          <a:xfrm>
+            <a:off x="804672" y="2040000"/>
+            <a:ext cx="4903431" cy="220000"/>
+          </a:xfrm>
+          <a:prstGeom prst="rect">
+            <a:avLst/>
+          </a:prstGeom>
+          <a:noFill/>
+          <a:ln/>
+        </p:spPr>
+        <p:txBody>
+          <a:bodyPr wrap="square" lIns="0" tIns="0" rIns="0" bIns="0" rtlCol="0" anchor="t"/>
+          <a:lstStyle/>
+          <a:p>
+            <a:pPr indent="0" marL="0">
+              <a:buNone/>
+            </a:pPr>
+            <a:r>
+              <a:rPr lang="en-US" sz="1100" b="1" spc="100" kern="0" dirty="0">
+                <a:solidFill>
+                  <a:srgbClr val="2E7D7D"/>
+                </a:solidFill>
+                <a:latin typeface="Arial" pitchFamily="34" charset="0"/>
+                <a:ea typeface="Arial" pitchFamily="34" charset="-122"/>
+                <a:cs typeface="Arial" pitchFamily="34" charset="-120"/>
+              </a:rPr>
+              <a:t>EL ESCRITORIO</a:t>
+            </a:r>
+            <a:endParaRPr lang="en-US" sz="1100" dirty="0"/>
+          </a:p>
+        </p:txBody>
+      </p:sp>
+      <p:sp>
+        <p:nvSpPr>
+          <p:cNvPr id="6" name="Shape"/>
+          <p:cNvSpPr/>
+          <p:nvPr/>
+        </p:nvSpPr>
+        <p:spPr>
+          <a:xfrm>
+            <a:off x="804672" y="2430000"/>
+            <a:ext cx="230000" cy="300000"/>
+          </a:xfrm>
+          <a:prstGeom prst="rect">
+            <a:avLst/>
+          </a:prstGeom>
+          <a:solidFill>
+            <a:srgbClr val="FFFFFF"/>
+          </a:solidFill>
+          <a:ln w="9525">
+            <a:solidFill>
+              <a:srgbClr val="16262E"/>
+            </a:solidFill>
+            <a:prstDash val="solid"/>
+          </a:ln>
+        </p:spPr>
+      </p:sp>
+      <p:sp>
+        <p:nvSpPr>
+          <p:cNvPr id="7" name="Shape"/>
+          <p:cNvSpPr/>
+          <p:nvPr/>
+        </p:nvSpPr>
+        <p:spPr>
+          <a:xfrm>
+            <a:off x="1094672" y="2430000"/>
+            <a:ext cx="230000" cy="300000"/>
+          </a:xfrm>
+          <a:prstGeom prst="rect">
+            <a:avLst/>
+          </a:prstGeom>
+          <a:solidFill>
+            <a:srgbClr val="FFFFFF"/>
+          </a:solidFill>
+          <a:ln w="9525">
+            <a:solidFill>
+              <a:srgbClr val="16262E"/>
+            </a:solidFill>
+            <a:prstDash val="solid"/>
+          </a:ln>
+        </p:spPr>
+      </p:sp>
+      <p:sp>
+        <p:nvSpPr>
+          <p:cNvPr id="8" name="Shape"/>
+          <p:cNvSpPr/>
+          <p:nvPr/>
+        </p:nvSpPr>
+        <p:spPr>
+          <a:xfrm>
+            <a:off x="1384672" y="2430000"/>
+            <a:ext cx="230000" cy="300000"/>
+          </a:xfrm>
+          <a:prstGeom prst="rect">
+            <a:avLst/>
+          </a:prstGeom>
+          <a:solidFill>
+            <a:srgbClr val="FFFFFF"/>
+          </a:solidFill>
+          <a:ln w="9525">
+            <a:solidFill>
+              <a:srgbClr val="16262E"/>
+            </a:solidFill>
+            <a:prstDash val="solid"/>
+          </a:ln>
+        </p:spPr>
+      </p:sp>
+      <p:sp>
+        <p:nvSpPr>
+          <p:cNvPr id="9" name="Shape"/>
+          <p:cNvSpPr/>
+          <p:nvPr/>
+        </p:nvSpPr>
+        <p:spPr>
+          <a:xfrm>
+            <a:off x="1714672" y="2460000"/>
+            <a:ext cx="280000" cy="240000"/>
+          </a:xfrm>
+          <a:prstGeom prst="rightArrow">
+            <a:avLst/>
+          </a:prstGeom>
+          <a:solidFill>
+            <a:srgbClr val="2E7D7D"/>
+          </a:solidFill>
+          <a:ln w="12700">
+            <a:solidFill>
+              <a:srgbClr val="2E7D7D"/>
+            </a:solidFill>
+            <a:prstDash val="solid"/>
+          </a:ln>
+        </p:spPr>
+      </p:sp>
+      <p:sp>
+        <p:nvSpPr>
+          <p:cNvPr id="10" name="Shape"/>
+          <p:cNvSpPr/>
+          <p:nvPr/>
+        </p:nvSpPr>
+        <p:spPr>
+          <a:xfrm>
+            <a:off x="2074672" y="2370000"/>
+            <a:ext cx="1900000" cy="420000"/>
+          </a:xfrm>
+          <a:prstGeom prst="roundRect">
+            <a:avLst>
+              <a:gd name="adj" fmla="val 30000"/>
+            </a:avLst>
+          </a:prstGeom>
+          <a:solidFill>
+            <a:srgbClr val="2E7D7D"/>
+          </a:solidFill>
+          <a:ln w="12700">
+            <a:solidFill>
+              <a:srgbClr val="2E7D7D"/>
+            </a:solidFill>
+            <a:prstDash val="solid"/>
+          </a:ln>
+        </p:spPr>
+      </p:sp>
+      <p:sp>
+        <p:nvSpPr>
+          <p:cNvPr id="11" name="Text"/>
+          <p:cNvSpPr txBox="1"/>
+          <p:nvPr/>
+        </p:nvSpPr>
+        <p:spPr>
+          <a:xfrm>
+            <a:off x="2074672" y="2370000"/>
+            <a:ext cx="1900000" cy="420000"/>
+          </a:xfrm>
+          <a:prstGeom prst="rect">
+            <a:avLst/>
+          </a:prstGeom>
+          <a:noFill/>
+          <a:ln/>
+        </p:spPr>
+        <p:txBody>
+          <a:bodyPr wrap="square" lIns="0" tIns="0" rIns="0" bIns="0" rtlCol="0" anchor="ctr"/>
+          <a:lstStyle/>
+          <a:p>
+            <a:pPr algn="ctr" indent="0" marL="0">
+              <a:buNone/>
+            </a:pPr>
+            <a:r>
+              <a:rPr lang="en-US" sz="1050" b="1" dirty="0">
+                <a:solidFill>
+                  <a:srgbClr val="FFFFFF"/>
+                </a:solidFill>
+                <a:latin typeface="Arial" pitchFamily="34" charset="0"/>
+                <a:ea typeface="Arial" pitchFamily="34" charset="-122"/>
+                <a:cs typeface="Arial" pitchFamily="34" charset="-120"/>
+              </a:rPr>
+              <a:t>ventana de contexto</a:t>
+            </a:r>
+            <a:endParaRPr lang="en-US" sz="1050" dirty="0"/>
+          </a:p>
+        </p:txBody>
+      </p:sp>
+      <p:sp>
+        <p:nvSpPr>
+          <p:cNvPr id="12" name="Shape"/>
+          <p:cNvSpPr/>
+          <p:nvPr/>
+        </p:nvSpPr>
+        <p:spPr>
+          <a:xfrm>
+            <a:off x="4054672" y="2460000"/>
+            <a:ext cx="280000" cy="240000"/>
+          </a:xfrm>
+          <a:prstGeom prst="rightArrow">
+            <a:avLst/>
+          </a:prstGeom>
+          <a:solidFill>
+            <a:srgbClr val="2E7D7D"/>
+          </a:solidFill>
+          <a:ln w="12700">
+            <a:solidFill>
+              <a:srgbClr val="2E7D7D"/>
+            </a:solidFill>
+            <a:prstDash val="solid"/>
+          </a:ln>
+        </p:spPr>
+      </p:sp>
+      <p:sp>
+        <p:nvSpPr>
+          <p:cNvPr id="13" name="Shape"/>
+          <p:cNvSpPr/>
+          <p:nvPr/>
+        </p:nvSpPr>
+        <p:spPr>
+          <a:xfrm>
+            <a:off x="4414672" y="2370000"/>
+            <a:ext cx="1150000" cy="420000"/>
+          </a:xfrm>
+          <a:prstGeom prst="roundRect">
+            <a:avLst>
+              <a:gd name="adj" fmla="val 30000"/>
+            </a:avLst>
+          </a:prstGeom>
+          <a:solidFill>
+            <a:srgbClr val="16262E"/>
+          </a:solidFill>
+          <a:ln w="12700">
+            <a:solidFill>
+              <a:srgbClr val="16262E"/>
+            </a:solidFill>
+            <a:prstDash val="solid"/>
+          </a:ln>
+        </p:spPr>
+      </p:sp>
+      <p:sp>
+        <p:nvSpPr>
+          <p:cNvPr id="14" name="Text"/>
+          <p:cNvSpPr txBox="1"/>
+          <p:nvPr/>
+        </p:nvSpPr>
+        <p:spPr>
+          <a:xfrm>
+            <a:off x="4414672" y="2370000"/>
+            <a:ext cx="1150000" cy="420000"/>
+          </a:xfrm>
+          <a:prstGeom prst="rect">
+            <a:avLst/>
+          </a:prstGeom>
+          <a:noFill/>
+          <a:ln/>
+        </p:spPr>
+        <p:txBody>
+          <a:bodyPr wrap="square" lIns="0" tIns="0" rIns="0" bIns="0" rtlCol="0" anchor="ctr"/>
+          <a:lstStyle/>
+          <a:p>
+            <a:pPr algn="ctr" indent="0" marL="0">
+              <a:buNone/>
+            </a:pPr>
+            <a:r>
+              <a:rPr lang="en-US" sz="1050" b="1" dirty="0">
+                <a:solidFill>
+                  <a:srgbClr val="FFFFFF"/>
+                </a:solidFill>
+                <a:latin typeface="Arial" pitchFamily="34" charset="0"/>
+                <a:ea typeface="Arial" pitchFamily="34" charset="-122"/>
+                <a:cs typeface="Arial" pitchFamily="34" charset="-120"/>
+              </a:rPr>
+              <a:t>respuesta</a:t>
+            </a:r>
+            <a:endParaRPr lang="en-US" sz="1050" dirty="0"/>
+          </a:p>
+        </p:txBody>
+      </p:sp>
+      <p:sp>
+        <p:nvSpPr>
+          <p:cNvPr id="15" name="Text"/>
+          <p:cNvSpPr txBox="1"/>
+          <p:nvPr/>
+        </p:nvSpPr>
+        <p:spPr>
+          <a:xfrm>
+            <a:off x="804672" y="2980000"/>
+            <a:ext cx="4903431" cy="330000"/>
+          </a:xfrm>
+          <a:prstGeom prst="rect">
+            <a:avLst/>
+          </a:prstGeom>
+          <a:noFill/>
+          <a:ln/>
+        </p:spPr>
+        <p:txBody>
+          <a:bodyPr wrap="square" lIns="0" tIns="0" rIns="0" bIns="0" rtlCol="0" anchor="t"/>
+          <a:lstStyle/>
+          <a:p>
+            <a:pPr indent="0" marL="0">
+              <a:buNone/>
+            </a:pPr>
+            <a:r>
+              <a:rPr lang="en-US" sz="1600" b="1" dirty="0">
+                <a:solidFill>
+                  <a:srgbClr val="16262E"/>
+                </a:solidFill>
+                <a:latin typeface="Arial" pitchFamily="34" charset="0"/>
+                <a:ea typeface="Arial" pitchFamily="34" charset="-122"/>
+                <a:cs typeface="Arial" pitchFamily="34" charset="-120"/>
+              </a:rPr>
+              <a:t>Ventana de contexto: todo sobre la mesa</a:t>
+            </a:r>
+            <a:endParaRPr lang="en-US" sz="1600" dirty="0"/>
+          </a:p>
+        </p:txBody>
+      </p:sp>
+      <p:sp>
+        <p:nvSpPr>
+          <p:cNvPr id="16" name="Text"/>
+          <p:cNvSpPr txBox="1"/>
+          <p:nvPr/>
+        </p:nvSpPr>
+        <p:spPr>
+          <a:xfrm>
+            <a:off x="804672" y="3410000"/>
+            <a:ext cx="4903431" cy="2000000"/>
+          </a:xfrm>
+          <a:prstGeom prst="rect">
+            <a:avLst/>
+          </a:prstGeom>
+          <a:noFill/>
+          <a:ln/>
+        </p:spPr>
+        <p:txBody>
+          <a:bodyPr wrap="square" lIns="0" tIns="0" rIns="0" bIns="0" rtlCol="0" anchor="t"/>
+          <a:lstStyle/>
+          <a:p>
+            <a:pPr indent="0" marL="0">
+              <a:lnSpc>
+                <a:spcPct val="108000"/>
+              </a:lnSpc>
+              <a:spcAft>
+                <a:spcPts val="650"/>
+              </a:spcAft>
+              <a:buNone/>
+            </a:pPr>
+            <a:r>
+              <a:rPr lang="en-US" sz="1300" dirty="0">
+                <a:solidFill>
+                  <a:srgbClr val="16262E"/>
+                </a:solidFill>
+                <a:latin typeface="Calibri" pitchFamily="34" charset="0"/>
+                <a:ea typeface="Calibri" pitchFamily="34" charset="-122"/>
+                <a:cs typeface="Calibri" pitchFamily="34" charset="-120"/>
+              </a:rPr>
+              <a:t>Tú eliges qué entra. El modelo lee lo que le pusiste enfrente y nada más.</a:t>
+            </a:r>
+            <a:endParaRPr lang="en-US" sz="1300" dirty="0"/>
+          </a:p>
+          <a:p>
+            <a:pPr indent="0" marL="0">
+              <a:lnSpc>
+                <a:spcPct val="108000"/>
+              </a:lnSpc>
+              <a:spcAft>
+                <a:spcPts val="650"/>
+              </a:spcAft>
+              <a:buNone/>
+            </a:pPr>
+            <a:r>
+              <a:rPr lang="en-US" sz="1300" dirty="0">
+                <a:solidFill>
+                  <a:srgbClr val="16262E"/>
+                </a:solidFill>
+                <a:latin typeface="Calibri" pitchFamily="34" charset="0"/>
+                <a:ea typeface="Calibri" pitchFamily="34" charset="-122"/>
+                <a:cs typeface="Calibri" pitchFamily="34" charset="-120"/>
+              </a:rPr>
+              <a:t>Cada pregunta vuelve a procesar todo lo que está en la mesa: a más páginas, más costo y más espera.</a:t>
+            </a:r>
+            <a:endParaRPr lang="en-US" sz="1300" dirty="0"/>
+          </a:p>
+          <a:p>
+            <a:pPr indent="0" marL="0">
+              <a:lnSpc>
+                <a:spcPct val="108000"/>
+              </a:lnSpc>
+              <a:spcAft>
+                <a:spcPts val="650"/>
+              </a:spcAft>
+              <a:buNone/>
+            </a:pPr>
+            <a:r>
+              <a:rPr lang="en-US" sz="1300" dirty="0">
+                <a:solidFill>
+                  <a:srgbClr val="16262E"/>
+                </a:solidFill>
+                <a:latin typeface="Calibri" pitchFamily="34" charset="0"/>
+                <a:ea typeface="Calibri" pitchFamily="34" charset="-122"/>
+                <a:cs typeface="Calibri" pitchFamily="34" charset="-120"/>
+              </a:rPr>
+              <a:t>Falla por saturación. Entre más texto hay en la mesa, peor aprovecha cada parte, sobre todo lo que queda en medio, y no te avisa.</a:t>
+            </a:r>
+            <a:endParaRPr lang="en-US" sz="1300" dirty="0"/>
+          </a:p>
+        </p:txBody>
+      </p:sp>
+      <p:sp>
+        <p:nvSpPr>
+          <p:cNvPr id="17" name="Shape"/>
+          <p:cNvSpPr/>
+          <p:nvPr/>
+        </p:nvSpPr>
+        <p:spPr>
+          <a:xfrm>
+            <a:off x="6245847" y="1850000"/>
+            <a:ext cx="5378919" cy="3700000"/>
+          </a:xfrm>
+          <a:prstGeom prst="roundRect">
+            <a:avLst>
+              <a:gd name="adj" fmla="val 2933"/>
+            </a:avLst>
+          </a:prstGeom>
+          <a:solidFill>
+            <a:srgbClr val="F2F5F6"/>
+          </a:solidFill>
+          <a:ln w="12700">
+            <a:solidFill>
+              <a:srgbClr val="F2F5F6"/>
+            </a:solidFill>
+            <a:prstDash val="solid"/>
+          </a:ln>
+        </p:spPr>
+      </p:sp>
+      <p:sp>
+        <p:nvSpPr>
+          <p:cNvPr id="18" name="Text"/>
+          <p:cNvSpPr txBox="1"/>
+          <p:nvPr/>
+        </p:nvSpPr>
+        <p:spPr>
+          <a:xfrm>
+            <a:off x="6483591" y="2040000"/>
+            <a:ext cx="4903431" cy="220000"/>
+          </a:xfrm>
+          <a:prstGeom prst="rect">
+            <a:avLst/>
+          </a:prstGeom>
+          <a:noFill/>
+          <a:ln/>
+        </p:spPr>
+        <p:txBody>
+          <a:bodyPr wrap="square" lIns="0" tIns="0" rIns="0" bIns="0" rtlCol="0" anchor="t"/>
+          <a:lstStyle/>
+          <a:p>
+            <a:pPr indent="0" marL="0">
+              <a:buNone/>
+            </a:pPr>
+            <a:r>
+              <a:rPr lang="en-US" sz="1100" b="1" spc="100" kern="0" dirty="0">
+                <a:solidFill>
+                  <a:srgbClr val="2E7D7D"/>
+                </a:solidFill>
+                <a:latin typeface="Arial" pitchFamily="34" charset="0"/>
+                <a:ea typeface="Arial" pitchFamily="34" charset="-122"/>
+                <a:cs typeface="Arial" pitchFamily="34" charset="-120"/>
+              </a:rPr>
+              <a:t>LA BIBLIOTECA CON BIBLIOTECARIO</a:t>
+            </a:r>
+            <a:endParaRPr lang="en-US" sz="1100" dirty="0"/>
+          </a:p>
+        </p:txBody>
+      </p:sp>
+      <p:sp>
+        <p:nvSpPr>
+          <p:cNvPr id="19" name="Shape"/>
+          <p:cNvSpPr/>
+          <p:nvPr/>
+        </p:nvSpPr>
+        <p:spPr>
+          <a:xfrm>
+            <a:off x="6483591" y="2370000"/>
+            <a:ext cx="110000" cy="180000"/>
+          </a:xfrm>
+          <a:prstGeom prst="rect">
+            <a:avLst/>
+          </a:prstGeom>
+          <a:solidFill>
+            <a:srgbClr val="FFFFFF"/>
+          </a:solidFill>
+          <a:ln w="9525">
+            <a:solidFill>
+              <a:srgbClr val="16262E"/>
+            </a:solidFill>
+            <a:prstDash val="solid"/>
+          </a:ln>
+        </p:spPr>
+      </p:sp>
+      <p:sp>
+        <p:nvSpPr>
+          <p:cNvPr id="20" name="Shape"/>
+          <p:cNvSpPr/>
+          <p:nvPr/>
+        </p:nvSpPr>
+        <p:spPr>
+          <a:xfrm>
+            <a:off x="6633591" y="2370000"/>
+            <a:ext cx="110000" cy="180000"/>
+          </a:xfrm>
+          <a:prstGeom prst="rect">
+            <a:avLst/>
+          </a:prstGeom>
+          <a:solidFill>
+            <a:srgbClr val="FFFFFF"/>
+          </a:solidFill>
+          <a:ln w="9525">
+            <a:solidFill>
+              <a:srgbClr val="16262E"/>
+            </a:solidFill>
+            <a:prstDash val="solid"/>
+          </a:ln>
+        </p:spPr>
+      </p:sp>
+      <p:sp>
+        <p:nvSpPr>
+          <p:cNvPr id="21" name="Shape"/>
+          <p:cNvSpPr/>
+          <p:nvPr/>
+        </p:nvSpPr>
+        <p:spPr>
+          <a:xfrm>
+            <a:off x="6783591" y="2370000"/>
+            <a:ext cx="110000" cy="180000"/>
+          </a:xfrm>
+          <a:prstGeom prst="rect">
+            <a:avLst/>
+          </a:prstGeom>
+          <a:solidFill>
+            <a:srgbClr val="FFFFFF"/>
+          </a:solidFill>
+          <a:ln w="9525">
+            <a:solidFill>
+              <a:srgbClr val="16262E"/>
+            </a:solidFill>
+            <a:prstDash val="solid"/>
+          </a:ln>
+        </p:spPr>
+      </p:sp>
+      <p:sp>
+        <p:nvSpPr>
+          <p:cNvPr id="22" name="Shape"/>
+          <p:cNvSpPr/>
+          <p:nvPr/>
+        </p:nvSpPr>
+        <p:spPr>
+          <a:xfrm>
+            <a:off x="6933591" y="2370000"/>
+            <a:ext cx="110000" cy="180000"/>
+          </a:xfrm>
+          <a:prstGeom prst="rect">
+            <a:avLst/>
+          </a:prstGeom>
+          <a:solidFill>
+            <a:srgbClr val="FFFFFF"/>
+          </a:solidFill>
+          <a:ln w="9525">
+            <a:solidFill>
+              <a:srgbClr val="16262E"/>
+            </a:solidFill>
+            <a:prstDash val="solid"/>
+          </a:ln>
+        </p:spPr>
+      </p:sp>
+      <p:sp>
+        <p:nvSpPr>
+          <p:cNvPr id="23" name="Shape"/>
+          <p:cNvSpPr/>
+          <p:nvPr/>
+        </p:nvSpPr>
+        <p:spPr>
+          <a:xfrm>
+            <a:off x="7083591" y="2370000"/>
+            <a:ext cx="110000" cy="180000"/>
+          </a:xfrm>
+          <a:prstGeom prst="rect">
+            <a:avLst/>
+          </a:prstGeom>
+          <a:solidFill>
+            <a:srgbClr val="FFFFFF"/>
+          </a:solidFill>
+          <a:ln w="9525">
+            <a:solidFill>
+              <a:srgbClr val="16262E"/>
+            </a:solidFill>
+            <a:prstDash val="solid"/>
+          </a:ln>
+        </p:spPr>
+      </p:sp>
+      <p:sp>
+        <p:nvSpPr>
+          <p:cNvPr id="24" name="Shape"/>
+          <p:cNvSpPr/>
+          <p:nvPr/>
+        </p:nvSpPr>
+        <p:spPr>
+          <a:xfrm>
+            <a:off x="7233591" y="2370000"/>
+            <a:ext cx="110000" cy="180000"/>
+          </a:xfrm>
+          <a:prstGeom prst="rect">
+            <a:avLst/>
+          </a:prstGeom>
+          <a:solidFill>
+            <a:srgbClr val="FFFFFF"/>
+          </a:solidFill>
+          <a:ln w="9525">
+            <a:solidFill>
+              <a:srgbClr val="16262E"/>
+            </a:solidFill>
+            <a:prstDash val="solid"/>
+          </a:ln>
+        </p:spPr>
+      </p:sp>
+      <p:sp>
+        <p:nvSpPr>
+          <p:cNvPr id="25" name="Shape"/>
+          <p:cNvSpPr/>
+          <p:nvPr/>
+        </p:nvSpPr>
+        <p:spPr>
+          <a:xfrm>
+            <a:off x="6483591" y="2585000"/>
+            <a:ext cx="110000" cy="180000"/>
+          </a:xfrm>
+          <a:prstGeom prst="rect">
+            <a:avLst/>
+          </a:prstGeom>
+          <a:solidFill>
+            <a:srgbClr val="FFFFFF"/>
+          </a:solidFill>
+          <a:ln w="9525">
+            <a:solidFill>
+              <a:srgbClr val="16262E"/>
+            </a:solidFill>
+            <a:prstDash val="solid"/>
+          </a:ln>
+        </p:spPr>
+      </p:sp>
+      <p:sp>
+        <p:nvSpPr>
+          <p:cNvPr id="26" name="Shape"/>
+          <p:cNvSpPr/>
+          <p:nvPr/>
+        </p:nvSpPr>
+        <p:spPr>
+          <a:xfrm>
+            <a:off x="6633591" y="2585000"/>
+            <a:ext cx="110000" cy="180000"/>
+          </a:xfrm>
+          <a:prstGeom prst="rect">
+            <a:avLst/>
+          </a:prstGeom>
+          <a:solidFill>
+            <a:srgbClr val="FFFFFF"/>
+          </a:solidFill>
+          <a:ln w="9525">
+            <a:solidFill>
+              <a:srgbClr val="16262E"/>
+            </a:solidFill>
+            <a:prstDash val="solid"/>
+          </a:ln>
+        </p:spPr>
+      </p:sp>
+      <p:sp>
+        <p:nvSpPr>
+          <p:cNvPr id="27" name="Shape"/>
+          <p:cNvSpPr/>
+          <p:nvPr/>
+        </p:nvSpPr>
+        <p:spPr>
+          <a:xfrm>
+            <a:off x="6783591" y="2585000"/>
+            <a:ext cx="110000" cy="180000"/>
+          </a:xfrm>
+          <a:prstGeom prst="rect">
+            <a:avLst/>
+          </a:prstGeom>
+          <a:solidFill>
+            <a:srgbClr val="FFFFFF"/>
+          </a:solidFill>
+          <a:ln w="9525">
+            <a:solidFill>
+              <a:srgbClr val="16262E"/>
+            </a:solidFill>
+            <a:prstDash val="solid"/>
+          </a:ln>
+        </p:spPr>
+      </p:sp>
+      <p:sp>
+        <p:nvSpPr>
+          <p:cNvPr id="28" name="Shape"/>
+          <p:cNvSpPr/>
+          <p:nvPr/>
+        </p:nvSpPr>
+        <p:spPr>
+          <a:xfrm>
+            <a:off x="6933591" y="2585000"/>
+            <a:ext cx="110000" cy="180000"/>
+          </a:xfrm>
+          <a:prstGeom prst="rect">
+            <a:avLst/>
+          </a:prstGeom>
+          <a:solidFill>
+            <a:srgbClr val="FFFFFF"/>
+          </a:solidFill>
+          <a:ln w="9525">
+            <a:solidFill>
+              <a:srgbClr val="16262E"/>
+            </a:solidFill>
+            <a:prstDash val="solid"/>
+          </a:ln>
+        </p:spPr>
+      </p:sp>
+      <p:sp>
+        <p:nvSpPr>
+          <p:cNvPr id="29" name="Shape"/>
+          <p:cNvSpPr/>
+          <p:nvPr/>
+        </p:nvSpPr>
+        <p:spPr>
+          <a:xfrm>
+            <a:off x="7083591" y="2585000"/>
+            <a:ext cx="110000" cy="180000"/>
+          </a:xfrm>
+          <a:prstGeom prst="rect">
+            <a:avLst/>
+          </a:prstGeom>
+          <a:solidFill>
+            <a:srgbClr val="FFFFFF"/>
+          </a:solidFill>
+          <a:ln w="9525">
+            <a:solidFill>
+              <a:srgbClr val="16262E"/>
+            </a:solidFill>
+            <a:prstDash val="solid"/>
+          </a:ln>
+        </p:spPr>
+      </p:sp>
+      <p:sp>
+        <p:nvSpPr>
+          <p:cNvPr id="30" name="Shape"/>
+          <p:cNvSpPr/>
+          <p:nvPr/>
+        </p:nvSpPr>
+        <p:spPr>
+          <a:xfrm>
+            <a:off x="7233591" y="2585000"/>
+            <a:ext cx="110000" cy="180000"/>
+          </a:xfrm>
+          <a:prstGeom prst="rect">
+            <a:avLst/>
+          </a:prstGeom>
+          <a:solidFill>
+            <a:srgbClr val="FFFFFF"/>
+          </a:solidFill>
+          <a:ln w="9525">
+            <a:solidFill>
+              <a:srgbClr val="16262E"/>
+            </a:solidFill>
+            <a:prstDash val="solid"/>
+          </a:ln>
+        </p:spPr>
+      </p:sp>
+      <p:sp>
+        <p:nvSpPr>
+          <p:cNvPr id="31" name="Shape"/>
+          <p:cNvSpPr/>
+          <p:nvPr/>
+        </p:nvSpPr>
+        <p:spPr>
+          <a:xfrm>
+            <a:off x="7403591" y="2460000"/>
+            <a:ext cx="240000" cy="240000"/>
+          </a:xfrm>
+          <a:prstGeom prst="rightArrow">
+            <a:avLst/>
+          </a:prstGeom>
+          <a:solidFill>
+            <a:srgbClr val="2E7D7D"/>
+          </a:solidFill>
+          <a:ln w="12700">
+            <a:solidFill>
+              <a:srgbClr val="2E7D7D"/>
+            </a:solidFill>
+            <a:prstDash val="solid"/>
+          </a:ln>
+        </p:spPr>
+      </p:sp>
+      <p:sp>
+        <p:nvSpPr>
+          <p:cNvPr id="32" name="Shape"/>
+          <p:cNvSpPr/>
+          <p:nvPr/>
+        </p:nvSpPr>
+        <p:spPr>
+          <a:xfrm>
+            <a:off x="7703591" y="2370000"/>
+            <a:ext cx="950000" cy="420000"/>
+          </a:xfrm>
+          <a:prstGeom prst="roundRect">
+            <a:avLst>
+              <a:gd name="adj" fmla="val 30000"/>
+            </a:avLst>
+          </a:prstGeom>
+          <a:solidFill>
+            <a:srgbClr val="2E7D7D"/>
+          </a:solidFill>
+          <a:ln w="12700">
+            <a:solidFill>
+              <a:srgbClr val="2E7D7D"/>
+            </a:solidFill>
+            <a:prstDash val="solid"/>
+          </a:ln>
+        </p:spPr>
+      </p:sp>
+      <p:sp>
+        <p:nvSpPr>
+          <p:cNvPr id="33" name="Text"/>
+          <p:cNvSpPr txBox="1"/>
+          <p:nvPr/>
+        </p:nvSpPr>
+        <p:spPr>
+          <a:xfrm>
+            <a:off x="7703591" y="2370000"/>
+            <a:ext cx="950000" cy="420000"/>
+          </a:xfrm>
+          <a:prstGeom prst="rect">
+            <a:avLst/>
+          </a:prstGeom>
+          <a:noFill/>
+          <a:ln/>
+        </p:spPr>
+        <p:txBody>
+          <a:bodyPr wrap="square" lIns="0" tIns="0" rIns="0" bIns="0" rtlCol="0" anchor="ctr"/>
+          <a:lstStyle/>
+          <a:p>
+            <a:pPr algn="ctr" indent="0" marL="0">
+              <a:buNone/>
+            </a:pPr>
+            <a:r>
+              <a:rPr lang="en-US" sz="1050" b="1" dirty="0">
+                <a:solidFill>
+                  <a:srgbClr val="FFFFFF"/>
+                </a:solidFill>
+                <a:latin typeface="Arial" pitchFamily="34" charset="0"/>
+                <a:ea typeface="Arial" pitchFamily="34" charset="-122"/>
+                <a:cs typeface="Arial" pitchFamily="34" charset="-120"/>
+              </a:rPr>
+              <a:t>buscador</a:t>
+            </a:r>
+            <a:endParaRPr lang="en-US" sz="1050" dirty="0"/>
+          </a:p>
+        </p:txBody>
+      </p:sp>
+      <p:sp>
+        <p:nvSpPr>
+          <p:cNvPr id="34" name="Shape"/>
+          <p:cNvSpPr/>
+          <p:nvPr/>
+        </p:nvSpPr>
+        <p:spPr>
+          <a:xfrm>
+            <a:off x="8713591" y="2460000"/>
+            <a:ext cx="240000" cy="240000"/>
+          </a:xfrm>
+          <a:prstGeom prst="rightArrow">
+            <a:avLst/>
+          </a:prstGeom>
+          <a:solidFill>
+            <a:srgbClr val="2E7D7D"/>
+          </a:solidFill>
+          <a:ln w="12700">
+            <a:solidFill>
+              <a:srgbClr val="2E7D7D"/>
+            </a:solidFill>
+            <a:prstDash val="solid"/>
+          </a:ln>
+        </p:spPr>
+      </p:sp>
+      <p:sp>
+        <p:nvSpPr>
+          <p:cNvPr id="35" name="Shape"/>
+          <p:cNvSpPr/>
+          <p:nvPr/>
+        </p:nvSpPr>
+        <p:spPr>
+          <a:xfrm>
+            <a:off x="9013591" y="2430000"/>
+            <a:ext cx="230000" cy="300000"/>
+          </a:xfrm>
+          <a:prstGeom prst="rect">
+            <a:avLst/>
+          </a:prstGeom>
+          <a:solidFill>
+            <a:srgbClr val="F7E4D8"/>
+          </a:solidFill>
+          <a:ln w="9525">
+            <a:solidFill>
+              <a:srgbClr val="C85A28"/>
+            </a:solidFill>
+            <a:prstDash val="solid"/>
+          </a:ln>
+        </p:spPr>
+      </p:sp>
+      <p:sp>
+        <p:nvSpPr>
+          <p:cNvPr id="36" name="Shape"/>
+          <p:cNvSpPr/>
+          <p:nvPr/>
+        </p:nvSpPr>
+        <p:spPr>
+          <a:xfrm>
+            <a:off x="9293591" y="2430000"/>
+            <a:ext cx="230000" cy="300000"/>
+          </a:xfrm>
+          <a:prstGeom prst="rect">
+            <a:avLst/>
+          </a:prstGeom>
+          <a:solidFill>
+            <a:srgbClr val="F7E4D8"/>
+          </a:solidFill>
+          <a:ln w="9525">
+            <a:solidFill>
+              <a:srgbClr val="C85A28"/>
+            </a:solidFill>
+            <a:prstDash val="solid"/>
+          </a:ln>
+        </p:spPr>
+      </p:sp>
+      <p:sp>
+        <p:nvSpPr>
+          <p:cNvPr id="37" name="Shape"/>
+          <p:cNvSpPr/>
+          <p:nvPr/>
+        </p:nvSpPr>
+        <p:spPr>
+          <a:xfrm>
+            <a:off x="9583591" y="2460000"/>
+            <a:ext cx="240000" cy="240000"/>
+          </a:xfrm>
+          <a:prstGeom prst="rightArrow">
+            <a:avLst/>
+          </a:prstGeom>
+          <a:solidFill>
+            <a:srgbClr val="2E7D7D"/>
+          </a:solidFill>
+          <a:ln w="12700">
+            <a:solidFill>
+              <a:srgbClr val="2E7D7D"/>
+            </a:solidFill>
+            <a:prstDash val="solid"/>
+          </a:ln>
+        </p:spPr>
+      </p:sp>
+      <p:sp>
+        <p:nvSpPr>
+          <p:cNvPr id="38" name="Shape"/>
+          <p:cNvSpPr/>
+          <p:nvPr/>
+        </p:nvSpPr>
+        <p:spPr>
+          <a:xfrm>
+            <a:off x="9883591" y="2370000"/>
+            <a:ext cx="1000000" cy="420000"/>
+          </a:xfrm>
+          <a:prstGeom prst="roundRect">
+            <a:avLst>
+              <a:gd name="adj" fmla="val 30000"/>
+            </a:avLst>
+          </a:prstGeom>
+          <a:solidFill>
+            <a:srgbClr val="16262E"/>
+          </a:solidFill>
+          <a:ln w="12700">
+            <a:solidFill>
+              <a:srgbClr val="16262E"/>
+            </a:solidFill>
+            <a:prstDash val="solid"/>
+          </a:ln>
+        </p:spPr>
+      </p:sp>
+      <p:sp>
+        <p:nvSpPr>
+          <p:cNvPr id="39" name="Text"/>
+          <p:cNvSpPr txBox="1"/>
+          <p:nvPr/>
+        </p:nvSpPr>
+        <p:spPr>
+          <a:xfrm>
+            <a:off x="9883591" y="2370000"/>
+            <a:ext cx="1000000" cy="420000"/>
+          </a:xfrm>
+          <a:prstGeom prst="rect">
+            <a:avLst/>
+          </a:prstGeom>
+          <a:noFill/>
+          <a:ln/>
+        </p:spPr>
+        <p:txBody>
+          <a:bodyPr wrap="square" lIns="0" tIns="0" rIns="0" bIns="0" rtlCol="0" anchor="ctr"/>
+          <a:lstStyle/>
+          <a:p>
+            <a:pPr algn="ctr" indent="0" marL="0">
+              <a:buNone/>
+            </a:pPr>
+            <a:r>
+              <a:rPr lang="en-US" sz="1050" b="1" dirty="0">
+                <a:solidFill>
+                  <a:srgbClr val="FFFFFF"/>
+                </a:solidFill>
+                <a:latin typeface="Arial" pitchFamily="34" charset="0"/>
+                <a:ea typeface="Arial" pitchFamily="34" charset="-122"/>
+                <a:cs typeface="Arial" pitchFamily="34" charset="-120"/>
+              </a:rPr>
+              <a:t>respuesta</a:t>
+            </a:r>
+            <a:endParaRPr lang="en-US" sz="1050" dirty="0"/>
+          </a:p>
+        </p:txBody>
+      </p:sp>
+      <p:sp>
+        <p:nvSpPr>
+          <p:cNvPr id="40" name="Text"/>
+          <p:cNvSpPr txBox="1"/>
+          <p:nvPr/>
+        </p:nvSpPr>
+        <p:spPr>
+          <a:xfrm>
+            <a:off x="6483591" y="2980000"/>
+            <a:ext cx="4903431" cy="330000"/>
+          </a:xfrm>
+          <a:prstGeom prst="rect">
+            <a:avLst/>
+          </a:prstGeom>
+          <a:noFill/>
+          <a:ln/>
+        </p:spPr>
+        <p:txBody>
+          <a:bodyPr wrap="square" lIns="0" tIns="0" rIns="0" bIns="0" rtlCol="0" anchor="t"/>
+          <a:lstStyle/>
+          <a:p>
+            <a:pPr indent="0" marL="0">
+              <a:buNone/>
+            </a:pPr>
+            <a:r>
+              <a:rPr lang="en-US" sz="1600" b="1" dirty="0">
+                <a:solidFill>
+                  <a:srgbClr val="16262E"/>
+                </a:solidFill>
+                <a:latin typeface="Arial" pitchFamily="34" charset="0"/>
+                <a:ea typeface="Arial" pitchFamily="34" charset="-122"/>
+                <a:cs typeface="Arial" pitchFamily="34" charset="-120"/>
+              </a:rPr>
+              <a:t>RAG: un buscador elige por ti</a:t>
+            </a:r>
+            <a:endParaRPr lang="en-US" sz="1600" dirty="0"/>
+          </a:p>
+        </p:txBody>
+      </p:sp>
+      <p:sp>
+        <p:nvSpPr>
+          <p:cNvPr id="41" name="Text"/>
+          <p:cNvSpPr txBox="1"/>
+          <p:nvPr/>
+        </p:nvSpPr>
+        <p:spPr>
+          <a:xfrm>
+            <a:off x="6483591" y="3410000"/>
+            <a:ext cx="4903431" cy="2000000"/>
+          </a:xfrm>
+          <a:prstGeom prst="rect">
+            <a:avLst/>
+          </a:prstGeom>
+          <a:noFill/>
+          <a:ln/>
+        </p:spPr>
+        <p:txBody>
+          <a:bodyPr wrap="square" lIns="0" tIns="0" rIns="0" bIns="0" rtlCol="0" anchor="t"/>
+          <a:lstStyle/>
+          <a:p>
+            <a:pPr indent="0" marL="0">
+              <a:lnSpc>
+                <a:spcPct val="108000"/>
+              </a:lnSpc>
+              <a:spcAft>
+                <a:spcPts val="650"/>
+              </a:spcAft>
+              <a:buNone/>
+            </a:pPr>
+            <a:r>
+              <a:rPr lang="en-US" sz="1300" dirty="0">
+                <a:solidFill>
+                  <a:srgbClr val="16262E"/>
+                </a:solidFill>
+                <a:latin typeface="Calibri" pitchFamily="34" charset="0"/>
+                <a:ea typeface="Calibri" pitchFamily="34" charset="-122"/>
+                <a:cs typeface="Calibri" pitchFamily="34" charset="-120"/>
+              </a:rPr>
+              <a:t>Los documentos se indexan una vez. Al preguntar, un buscador trae los fragmentos más cercanos y el modelo responde solo con esos.</a:t>
+            </a:r>
+            <a:endParaRPr lang="en-US" sz="1300" dirty="0"/>
+          </a:p>
+          <a:p>
+            <a:pPr indent="0" marL="0">
+              <a:lnSpc>
+                <a:spcPct val="108000"/>
+              </a:lnSpc>
+              <a:spcAft>
+                <a:spcPts val="650"/>
+              </a:spcAft>
+              <a:buNone/>
+            </a:pPr>
+            <a:r>
+              <a:rPr lang="en-US" sz="1300" dirty="0">
+                <a:solidFill>
+                  <a:srgbClr val="16262E"/>
+                </a:solidFill>
+                <a:latin typeface="Calibri" pitchFamily="34" charset="0"/>
+                <a:ea typeface="Calibri" pitchFamily="34" charset="-122"/>
+                <a:cs typeface="Calibri" pitchFamily="34" charset="-120"/>
+              </a:rPr>
+              <a:t>Armar y mantener el índice cuesta; después, cada consulta es barata aunque el acervo sea enorme.</a:t>
+            </a:r>
+            <a:endParaRPr lang="en-US" sz="1300" dirty="0"/>
+          </a:p>
+          <a:p>
+            <a:pPr indent="0" marL="0">
+              <a:lnSpc>
+                <a:spcPct val="108000"/>
+              </a:lnSpc>
+              <a:spcAft>
+                <a:spcPts val="650"/>
+              </a:spcAft>
+              <a:buNone/>
+            </a:pPr>
+            <a:r>
+              <a:rPr lang="en-US" sz="1300" dirty="0">
+                <a:solidFill>
+                  <a:srgbClr val="16262E"/>
+                </a:solidFill>
+                <a:latin typeface="Calibri" pitchFamily="34" charset="0"/>
+                <a:ea typeface="Calibri" pitchFamily="34" charset="-122"/>
+                <a:cs typeface="Calibri" pitchFamily="34" charset="-120"/>
+              </a:rPr>
+              <a:t>Falla por omisión. Si el buscador no trae el fragmento correcto, el modelo responde sin él y con el mismo aplomo.</a:t>
+            </a:r>
+            <a:endParaRPr lang="en-US" sz="1300" dirty="0"/>
+          </a:p>
+        </p:txBody>
+      </p:sp>
+      <p:sp>
+        <p:nvSpPr>
+          <p:cNvPr id="42" name="Shape"/>
+          <p:cNvSpPr/>
+          <p:nvPr/>
+        </p:nvSpPr>
+        <p:spPr>
+          <a:xfrm>
+            <a:off x="566928" y="5700000"/>
+            <a:ext cx="11057839" cy="594360"/>
+          </a:xfrm>
+          <a:prstGeom prst="roundRect">
+            <a:avLst>
+              <a:gd name="adj" fmla="val 8235"/>
+            </a:avLst>
+          </a:prstGeom>
+          <a:solidFill>
+            <a:srgbClr val="F7E4D8"/>
+          </a:solidFill>
+          <a:ln w="12700">
+            <a:solidFill>
+              <a:srgbClr val="F7E4D8"/>
+            </a:solidFill>
+            <a:prstDash val="solid"/>
+          </a:ln>
+        </p:spPr>
+      </p:sp>
+      <p:sp>
+        <p:nvSpPr>
+          <p:cNvPr id="43" name="Text"/>
+          <p:cNvSpPr txBox="1"/>
+          <p:nvPr/>
+        </p:nvSpPr>
+        <p:spPr>
+          <a:xfrm>
+            <a:off x="804672" y="5700000"/>
+            <a:ext cx="10582351" cy="594360"/>
+          </a:xfrm>
+          <a:prstGeom prst="rect">
+            <a:avLst/>
+          </a:prstGeom>
+          <a:noFill/>
+          <a:ln/>
+        </p:spPr>
+        <p:txBody>
+          <a:bodyPr wrap="square" lIns="0" tIns="0" rIns="0" bIns="0" rtlCol="0" anchor="ctr"/>
+          <a:lstStyle/>
+          <a:p>
+            <a:pPr indent="0" marL="0">
+              <a:lnSpc>
+                <a:spcPct val="110000"/>
+              </a:lnSpc>
+              <a:buNone/>
+            </a:pPr>
+            <a:r>
+              <a:rPr lang="en-US" sz="1300" dirty="0">
+                <a:solidFill>
+                  <a:srgbClr val="16262E"/>
+                </a:solidFill>
+                <a:latin typeface="Calibri" pitchFamily="34" charset="0"/>
+                <a:ea typeface="Calibri" pitchFamily="34" charset="-122"/>
+                <a:cs typeface="Calibri" pitchFamily="34" charset="-120"/>
+              </a:rPr>
+              <a:t>Desde fuera no siempre sabes cuál te tocó: ChatGPT, con archivos largos, pasa del escritorio a la biblioteca sin avisarte. Como las dos fallan calladas, la regla es la misma: pide la cita y ve al párrafo.</a:t>
+            </a:r>
+            <a:endParaRPr lang="en-US" sz="1300" dirty="0"/>
+          </a:p>
+        </p:txBody>
+      </p:sp>
+      <p:sp>
+        <p:nvSpPr>
+          <p:cNvPr id="44" name="Text"/>
+          <p:cNvSpPr txBox="1"/>
+          <p:nvPr/>
+        </p:nvSpPr>
+        <p:spPr>
+          <a:xfrm>
+            <a:off x="566928" y="6360000"/>
+            <a:ext cx="11057839" cy="240000"/>
+          </a:xfrm>
+          <a:prstGeom prst="rect">
+            <a:avLst/>
+          </a:prstGeom>
+          <a:noFill/>
+          <a:ln/>
+        </p:spPr>
+        <p:txBody>
+          <a:bodyPr wrap="square" lIns="0" tIns="0" rIns="0" bIns="0" rtlCol="0" anchor="t"/>
+          <a:lstStyle/>
+          <a:p>
+            <a:pPr indent="0" marL="0">
+              <a:buNone/>
+            </a:pPr>
+            <a:r>
+              <a:rPr lang="en-US" sz="1000" dirty="0">
+                <a:solidFill>
+                  <a:srgbClr val="5A6B73"/>
+                </a:solidFill>
+                <a:latin typeface="Calibri" pitchFamily="34" charset="0"/>
+                <a:ea typeface="Calibri" pitchFamily="34" charset="-122"/>
+                <a:cs typeface="Calibri" pitchFamily="34" charset="-120"/>
+              </a:rPr>
+              <a:t>Fuentes: Lewis y otros (2020), arXiv:2005.11401 · Liu y otros (2024), arXiv:2307.03172 · OpenAI, «Optimizing File Uploads in ChatGPT Enterprise». Ligas en el anexo de la sesión.</a:t>
             </a:r>
             <a:endParaRPr lang="en-US" sz="1000" dirty="0"/>
           </a:p>
@@ -8247,7 +9910,7 @@
                 <a:ea typeface="Calibri" pitchFamily="34" charset="-122"/>
                 <a:cs typeface="Calibri" pitchFamily="34" charset="-120"/>
               </a:rPr>
-              <a:t>Receso de diez minutos</a:t>
+              <a:t>Receso de diez minutos, con charla opcional: ventana de contexto y RAG</a:t>
             </a:r>
             <a:endParaRPr lang="en-US" sz="1350" dirty="0"/>
           </a:p>
@@ -8529,7 +10192,7 @@
                 <a:ea typeface="Arial" pitchFamily="34" charset="-122"/>
                 <a:cs typeface="Arial" pitchFamily="34" charset="-120"/>
               </a:rPr>
-              <a:t>11:10</a:t>
+              <a:t>11:07</a:t>
             </a:r>
             <a:endParaRPr lang="en-US" sz="1300" dirty="0"/>
           </a:p>
@@ -10623,7 +12286,7 @@
                           <a:ea typeface="Calibri" pitchFamily="34" charset="-122"/>
                           <a:cs typeface="Calibri" pitchFamily="34" charset="-120"/>
                         </a:rPr>
-                        <a:t>NotebookLM, bloqueada</a:t>
+                        <a:t>NotebookLM (hoy Gemini Notebook), bloqueada</a:t>
                       </a:r>
                       <a:endParaRPr lang="en-US" sz="1250" dirty="0">
                         <a:latin typeface="Calibri" charset="0"/>
@@ -13704,7 +15367,7 @@
                 <a:ea typeface="Calibri" pitchFamily="34" charset="-122"/>
                 <a:cs typeface="Calibri" pitchFamily="34" charset="-120"/>
               </a:rPr>
-              <a:t>Equipo 5: activa la prueba de Elicit hoy y no antes. Son siete días y se vencen el 28.</a:t>
+              <a:t>Equipo 5: activa la prueba de Elicit hoy y no antes; son siete días y se vencen el 28. Equipo 4: la cuenta gratuita de You.com es hoy una prueba de 25 consultas; trabaja en Perplexity y usa You.com solo para contrastar.</a:t>
             </a:r>
             <a:endParaRPr lang="en-US" sz="1000" dirty="0"/>
           </a:p>

</xml_diff>